<commit_message>
Merged deck: 3 slides, drop duplicate FY26 summary
Co-Authored-By: Claude Opus 5.5 <noreply@anthropic.com>
Claude-Session: https://claude.ai/code/session_01X3b4nN4VQ8Ge4ucA4qFPyi
</commit_message>
<xml_diff>
--- a/B2B_PL_slajdy_kickoff_FY27.pptx
+++ b/B2B_PL_slajdy_kickoff_FY27.pptx
@@ -8,10 +8,9 @@
     <p:sldId id="256" r:id="rId2"/>
     <p:sldId id="257" r:id="rId3"/>
     <p:sldId id="258" r:id="rId4"/>
-    <p:sldId id="259" r:id="rId5"/>
   </p:sldIdLst>
   <p:notesMasterIdLst>
-    <p:notesMasterId r:id="rId6"/>
+    <p:notesMasterId r:id="rId5"/>
   </p:notesMasterIdLst>
   <p:sldSz cx="12192000" cy="6858000"/>
   <p:notesSz cx="6858000" cy="12192000"/>
@@ -681,7 +680,7 @@
           <a:p>
             <a:r>
               <a:rPr lang="en-US" dirty="0"/>
-              <a:t>Jeden slajd zamiast angielskich slajdów o panelu B2B. Założenia z business case FY26: 166 klientów, 928 zamówień, 464 tys. €. Panel się przyjął: 174 kont, 91% budżetu sprzedaży (94% planu do dziś), 59% klientów wraca z drugim zamówieniem. Słabo z liczbą zamówień (317 = 34% celu): klienci zamawiają rzadko i dużo, bez kampanii, bez kontaktu w sezonie, a korekty cen w Sage nie wracały do panelu. Stąd 4 learningi na FY27.</a:t>
+              <a:t>Wynik na 25.09.2026: 91% budżetu sprzedaży (94% planu do dziś), 73% kont z zamówieniem, ale tylko 34% celu zamówień. Średnie zamówienie 2,7× plan, bo klienci zamawiają rzadko i dużo. 1 października startuje nowa platforma: ceny i rabaty od razu w koszyku, kredyt kupiecki, rabat za krótszy termin płatności, automatyczne maile i program partnerski. Cele FY27: 900 tys. €, 1 125 zamówień.</a:t>
             </a:r>
             <a:endParaRPr lang="en-US" dirty="0"/>
           </a:p>
@@ -705,94 +704,6 @@
             <a:fld id="{F7021451-1387-4CA6-816F-3879F97B5CBC}" type="slidenum">
               <a:rPr lang="en-US"/>
               <a:t>3</a:t>
-            </a:fld>
-            <a:endParaRPr lang="en-US"/>
-          </a:p>
-        </p:txBody>
-      </p:sp>
-    </p:spTree>
-    <p:extLst>
-      <p:ext uri="{BB962C8B-B14F-4D97-AF65-F5344CB8AC3E}">
-        <p14:creationId xmlns:p14="http://schemas.microsoft.com/office/powerpoint/2010/main" val="1024086991"/>
-      </p:ext>
-    </p:extLst>
-  </p:cSld>
-  <p:clrMapOvr>
-    <a:masterClrMapping/>
-  </p:clrMapOvr>
-</p:notes>
-</file>
-
-<file path=ppt/notesSlides/notesSlide4.xml><?xml version="1.0" encoding="utf-8"?>
-<p:notes xmlns:a="http://schemas.openxmlformats.org/drawingml/2006/main" xmlns:r="http://schemas.openxmlformats.org/officeDocument/2006/relationships" xmlns:p="http://schemas.openxmlformats.org/presentationml/2006/main">
-  <p:cSld>
-    <p:spTree>
-      <p:nvGrpSpPr>
-        <p:cNvPr id="1" name=""/>
-        <p:cNvGrpSpPr/>
-        <p:nvPr/>
-      </p:nvGrpSpPr>
-      <p:grpSpPr>
-        <a:xfrm>
-          <a:off x="0" y="0"/>
-          <a:ext cx="0" cy="0"/>
-          <a:chOff x="0" y="0"/>
-          <a:chExt cx="0" cy="0"/>
-        </a:xfrm>
-      </p:grpSpPr>
-      <p:sp>
-        <p:nvSpPr>
-          <p:cNvPr id="2" name="Slide Image Placeholder 1"/>
-          <p:cNvSpPr>
-            <a:spLocks noGrp="1" noRot="1" noChangeAspect="1"/>
-          </p:cNvSpPr>
-          <p:nvPr>
-            <p:ph type="sldImg"/>
-          </p:nvPr>
-        </p:nvSpPr>
-        <p:spPr/>
-      </p:sp>
-      <p:sp>
-        <p:nvSpPr>
-          <p:cNvPr id="3" name="Notes Placeholder 2"/>
-          <p:cNvSpPr>
-            <a:spLocks noGrp="1"/>
-          </p:cNvSpPr>
-          <p:nvPr>
-            <p:ph type="body" idx="1"/>
-          </p:nvPr>
-        </p:nvSpPr>
-        <p:spPr/>
-        <p:txBody>
-          <a:bodyPr/>
-          <a:lstStyle/>
-          <a:p>
-            <a:r>
-              <a:rPr lang="en-US" dirty="0"/>
-              <a:t>Wynik na 25.09.2026: 91% budżetu sprzedaży (94% planu do dziś), 73% kont z zamówieniem, ale tylko 34% celu zamówień. Średnie zamówienie 2,7× plan, bo klienci zamawiają rzadko i dużo. 1 października startuje nowa platforma: ceny i rabaty od razu w koszyku, kredyt kupiecki, rabat za krótszy termin płatności, automatyczne maile i program partnerski. Cele FY27: 900 tys. €, 1 125 zamówień.</a:t>
-            </a:r>
-            <a:endParaRPr lang="en-US" dirty="0"/>
-          </a:p>
-        </p:txBody>
-      </p:sp>
-      <p:sp>
-        <p:nvSpPr>
-          <p:cNvPr id="4" name="Slide Number Placeholder 3"/>
-          <p:cNvSpPr>
-            <a:spLocks noGrp="1"/>
-          </p:cNvSpPr>
-          <p:nvPr>
-            <p:ph type="sldNum" sz="quarter" idx="10"/>
-          </p:nvPr>
-        </p:nvSpPr>
-        <p:spPr/>
-        <p:txBody>
-          <a:bodyPr/>
-          <a:lstStyle/>
-          <a:p>
-            <a:fld id="{F7021451-1387-4CA6-816F-3879F97B5CBC}" type="slidenum">
-              <a:rPr lang="en-US"/>
-              <a:t>4</a:t>
             </a:fld>
             <a:endParaRPr lang="en-US"/>
           </a:p>
@@ -3750,1366 +3661,6 @@
                 <a:ea typeface="Calibri" pitchFamily="34" charset="-122"/>
                 <a:cs typeface="Calibri" pitchFamily="34" charset="-120"/>
               </a:rPr>
-              <a:t>B2B PL – PODSUMOWANIE FY26</a:t>
-            </a:r>
-            <a:endParaRPr lang="en-US" sz="4000" dirty="0"/>
-          </a:p>
-        </p:txBody>
-      </p:sp>
-      <p:sp>
-        <p:nvSpPr>
-          <p:cNvPr id="3" name="Shape 1"/>
-          <p:cNvSpPr/>
-          <p:nvPr/>
-        </p:nvSpPr>
-        <p:spPr>
-          <a:xfrm>
-            <a:off x="411480" y="1188720"/>
-            <a:ext cx="2697480" cy="457200"/>
-          </a:xfrm>
-          <a:prstGeom prst="rect">
-            <a:avLst/>
-          </a:prstGeom>
-          <a:solidFill>
-            <a:srgbClr val="174769"/>
-          </a:solidFill>
-          <a:ln w="12700">
-            <a:solidFill>
-              <a:srgbClr val="174769"/>
-            </a:solidFill>
-            <a:prstDash val="solid"/>
-          </a:ln>
-        </p:spPr>
-      </p:sp>
-      <p:pic>
-        <p:nvPicPr>
-          <p:cNvPr id="4" name="Image 0" descr="preencoded.png">    </p:cNvPr>
-          <p:cNvPicPr>
-            <a:picLocks noChangeAspect="1"/>
-          </p:cNvPicPr>
-          <p:nvPr/>
-        </p:nvPicPr>
-        <p:blipFill>
-          <a:blip r:embed="rId1"/>
-          <a:stretch>
-            <a:fillRect/>
-          </a:stretch>
-        </p:blipFill>
-        <p:spPr>
-          <a:xfrm>
-            <a:off x="576072" y="1307592"/>
-            <a:ext cx="219456" cy="219456"/>
-          </a:xfrm>
-          <a:prstGeom prst="rect">
-            <a:avLst/>
-          </a:prstGeom>
-        </p:spPr>
-      </p:pic>
-      <p:sp>
-        <p:nvSpPr>
-          <p:cNvPr id="5" name="Text 2"/>
-          <p:cNvSpPr txBox="1"/>
-          <p:nvPr/>
-        </p:nvSpPr>
-        <p:spPr>
-          <a:xfrm>
-            <a:off x="886968" y="1188720"/>
-            <a:ext cx="2148840" cy="457200"/>
-          </a:xfrm>
-          <a:prstGeom prst="rect">
-            <a:avLst/>
-          </a:prstGeom>
-          <a:noFill/>
-          <a:ln/>
-        </p:spPr>
-        <p:txBody>
-          <a:bodyPr wrap="square" lIns="0" tIns="0" rIns="0" bIns="0" rtlCol="0" anchor="ctr"/>
-          <a:lstStyle/>
-          <a:p>
-            <a:pPr indent="0" marL="0">
-              <a:buNone/>
-            </a:pPr>
-            <a:r>
-              <a:rPr lang="en-US" sz="1600" b="1" dirty="0">
-                <a:solidFill>
-                  <a:srgbClr val="FFFFFF"/>
-                </a:solidFill>
-                <a:latin typeface="Calibri" pitchFamily="34" charset="0"/>
-                <a:ea typeface="Calibri" pitchFamily="34" charset="-122"/>
-                <a:cs typeface="Calibri" pitchFamily="34" charset="-120"/>
-              </a:rPr>
-              <a:t>Założenia</a:t>
-            </a:r>
-            <a:endParaRPr lang="en-US" sz="1600" dirty="0"/>
-          </a:p>
-        </p:txBody>
-      </p:sp>
-      <p:sp>
-        <p:nvSpPr>
-          <p:cNvPr id="6" name="Shape 3"/>
-          <p:cNvSpPr/>
-          <p:nvPr/>
-        </p:nvSpPr>
-        <p:spPr>
-          <a:xfrm>
-            <a:off x="411480" y="1737360"/>
-            <a:ext cx="2697480" cy="2880360"/>
-          </a:xfrm>
-          <a:prstGeom prst="rect">
-            <a:avLst/>
-          </a:prstGeom>
-          <a:solidFill>
-            <a:srgbClr val="FFFFFF"/>
-          </a:solidFill>
-          <a:ln w="15875">
-            <a:solidFill>
-              <a:srgbClr val="174769"/>
-            </a:solidFill>
-            <a:prstDash val="solid"/>
-          </a:ln>
-        </p:spPr>
-      </p:sp>
-      <p:sp>
-        <p:nvSpPr>
-          <p:cNvPr id="7" name="Text 4"/>
-          <p:cNvSpPr txBox="1"/>
-          <p:nvPr/>
-        </p:nvSpPr>
-        <p:spPr>
-          <a:xfrm>
-            <a:off x="548640" y="1874520"/>
-            <a:ext cx="2441448" cy="2651760"/>
-          </a:xfrm>
-          <a:prstGeom prst="rect">
-            <a:avLst/>
-          </a:prstGeom>
-          <a:noFill/>
-          <a:ln/>
-        </p:spPr>
-        <p:txBody>
-          <a:bodyPr wrap="square" lIns="0" tIns="0" rIns="0" bIns="0" rtlCol="0" anchor="t"/>
-          <a:lstStyle/>
-          <a:p>
-            <a:pPr marL="152400" indent="-152400">
-              <a:spcAft>
-                <a:spcPts val="500"/>
-              </a:spcAft>
-              <a:buSzPct val="100000"/>
-              <a:buChar char="•"/>
-            </a:pPr>
-            <a:r>
-              <a:rPr lang="en-US" sz="1250" dirty="0">
-                <a:solidFill>
-                  <a:srgbClr val="30597A"/>
-                </a:solidFill>
-                <a:latin typeface="Calibri" pitchFamily="34" charset="0"/>
-                <a:ea typeface="Calibri" pitchFamily="34" charset="-122"/>
-                <a:cs typeface="Calibri" pitchFamily="34" charset="-120"/>
-              </a:rPr>
-              <a:t>Własny kanał zamówień dla sklepów i hurtu: panel sbm-partners.com, 1. zamówienie 19.03.2026</a:t>
-            </a:r>
-            <a:endParaRPr lang="en-US" sz="1250" dirty="0"/>
-          </a:p>
-          <a:p>
-            <a:pPr marL="152400" indent="-152400">
-              <a:spcAft>
-                <a:spcPts val="500"/>
-              </a:spcAft>
-              <a:buSzPct val="100000"/>
-              <a:buChar char="•"/>
-            </a:pPr>
-            <a:r>
-              <a:rPr lang="en-US" sz="1250" dirty="0">
-                <a:solidFill>
-                  <a:srgbClr val="30597A"/>
-                </a:solidFill>
-                <a:latin typeface="Calibri" pitchFamily="34" charset="0"/>
-                <a:ea typeface="Calibri" pitchFamily="34" charset="-122"/>
-                <a:cs typeface="Calibri" pitchFamily="34" charset="-120"/>
-              </a:rPr>
-              <a:t>Business case FY26: 166 klientów, 464 tys. €, 928 zamówień, średnio 500 €</a:t>
-            </a:r>
-            <a:endParaRPr lang="en-US" sz="1250" dirty="0"/>
-          </a:p>
-        </p:txBody>
-      </p:sp>
-      <p:sp>
-        <p:nvSpPr>
-          <p:cNvPr id="8" name="Shape 5"/>
-          <p:cNvSpPr/>
-          <p:nvPr/>
-        </p:nvSpPr>
-        <p:spPr>
-          <a:xfrm>
-            <a:off x="3291840" y="1188720"/>
-            <a:ext cx="2697480" cy="457200"/>
-          </a:xfrm>
-          <a:prstGeom prst="rect">
-            <a:avLst/>
-          </a:prstGeom>
-          <a:solidFill>
-            <a:srgbClr val="174769"/>
-          </a:solidFill>
-          <a:ln w="12700">
-            <a:solidFill>
-              <a:srgbClr val="174769"/>
-            </a:solidFill>
-            <a:prstDash val="solid"/>
-          </a:ln>
-        </p:spPr>
-      </p:sp>
-      <p:pic>
-        <p:nvPicPr>
-          <p:cNvPr id="9" name="Image 1" descr="preencoded.png">    </p:cNvPr>
-          <p:cNvPicPr>
-            <a:picLocks noChangeAspect="1"/>
-          </p:cNvPicPr>
-          <p:nvPr/>
-        </p:nvPicPr>
-        <p:blipFill>
-          <a:blip r:embed="rId2"/>
-          <a:stretch>
-            <a:fillRect/>
-          </a:stretch>
-        </p:blipFill>
-        <p:spPr>
-          <a:xfrm>
-            <a:off x="3456432" y="1307592"/>
-            <a:ext cx="219456" cy="219456"/>
-          </a:xfrm>
-          <a:prstGeom prst="rect">
-            <a:avLst/>
-          </a:prstGeom>
-        </p:spPr>
-      </p:pic>
-      <p:sp>
-        <p:nvSpPr>
-          <p:cNvPr id="10" name="Text 6"/>
-          <p:cNvSpPr txBox="1"/>
-          <p:nvPr/>
-        </p:nvSpPr>
-        <p:spPr>
-          <a:xfrm>
-            <a:off x="3767328" y="1188720"/>
-            <a:ext cx="2148840" cy="457200"/>
-          </a:xfrm>
-          <a:prstGeom prst="rect">
-            <a:avLst/>
-          </a:prstGeom>
-          <a:noFill/>
-          <a:ln/>
-        </p:spPr>
-        <p:txBody>
-          <a:bodyPr wrap="square" lIns="0" tIns="0" rIns="0" bIns="0" rtlCol="0" anchor="ctr"/>
-          <a:lstStyle/>
-          <a:p>
-            <a:pPr indent="0" marL="0">
-              <a:buNone/>
-            </a:pPr>
-            <a:r>
-              <a:rPr lang="en-US" sz="1600" b="1" dirty="0">
-                <a:solidFill>
-                  <a:srgbClr val="FFFFFF"/>
-                </a:solidFill>
-                <a:latin typeface="Calibri" pitchFamily="34" charset="0"/>
-                <a:ea typeface="Calibri" pitchFamily="34" charset="-122"/>
-                <a:cs typeface="Calibri" pitchFamily="34" charset="-120"/>
-              </a:rPr>
-              <a:t>Jak to zrobiliśmy</a:t>
-            </a:r>
-            <a:endParaRPr lang="en-US" sz="1600" dirty="0"/>
-          </a:p>
-        </p:txBody>
-      </p:sp>
-      <p:sp>
-        <p:nvSpPr>
-          <p:cNvPr id="11" name="Shape 7"/>
-          <p:cNvSpPr/>
-          <p:nvPr/>
-        </p:nvSpPr>
-        <p:spPr>
-          <a:xfrm>
-            <a:off x="3291840" y="1737360"/>
-            <a:ext cx="2697480" cy="2880360"/>
-          </a:xfrm>
-          <a:prstGeom prst="rect">
-            <a:avLst/>
-          </a:prstGeom>
-          <a:solidFill>
-            <a:srgbClr val="FFFFFF"/>
-          </a:solidFill>
-          <a:ln w="15875">
-            <a:solidFill>
-              <a:srgbClr val="174769"/>
-            </a:solidFill>
-            <a:prstDash val="solid"/>
-          </a:ln>
-        </p:spPr>
-      </p:sp>
-      <p:sp>
-        <p:nvSpPr>
-          <p:cNvPr id="12" name="Text 8"/>
-          <p:cNvSpPr txBox="1"/>
-          <p:nvPr/>
-        </p:nvSpPr>
-        <p:spPr>
-          <a:xfrm>
-            <a:off x="3429000" y="1874520"/>
-            <a:ext cx="2441448" cy="2651760"/>
-          </a:xfrm>
-          <a:prstGeom prst="rect">
-            <a:avLst/>
-          </a:prstGeom>
-          <a:noFill/>
-          <a:ln/>
-        </p:spPr>
-        <p:txBody>
-          <a:bodyPr wrap="square" lIns="0" tIns="0" rIns="0" bIns="0" rtlCol="0" anchor="t"/>
-          <a:lstStyle/>
-          <a:p>
-            <a:pPr marL="152400" indent="-152400">
-              <a:spcAft>
-                <a:spcPts val="500"/>
-              </a:spcAft>
-              <a:buSzPct val="100000"/>
-              <a:buChar char="•"/>
-            </a:pPr>
-            <a:r>
-              <a:rPr lang="en-US" sz="1250" dirty="0">
-                <a:solidFill>
-                  <a:srgbClr val="30597A"/>
-                </a:solidFill>
-                <a:latin typeface="Calibri" pitchFamily="34" charset="0"/>
-                <a:ea typeface="Calibri" pitchFamily="34" charset="-122"/>
-                <a:cs typeface="Calibri" pitchFamily="34" charset="-120"/>
-              </a:rPr>
-              <a:t>Cała baza na panelu: rejestracja, konta, grupy cenowe</a:t>
-            </a:r>
-            <a:endParaRPr lang="en-US" sz="1250" dirty="0"/>
-          </a:p>
-          <a:p>
-            <a:pPr marL="152400" indent="-152400">
-              <a:spcAft>
-                <a:spcPts val="500"/>
-              </a:spcAft>
-              <a:buSzPct val="100000"/>
-              <a:buChar char="•"/>
-            </a:pPr>
-            <a:r>
-              <a:rPr lang="en-US" sz="1250" dirty="0">
-                <a:solidFill>
-                  <a:srgbClr val="30597A"/>
-                </a:solidFill>
-                <a:latin typeface="Calibri" pitchFamily="34" charset="0"/>
-                <a:ea typeface="Calibri" pitchFamily="34" charset="-122"/>
-                <a:cs typeface="Calibri" pitchFamily="34" charset="-120"/>
-              </a:rPr>
-              <a:t>Ceny netto z rabatem klienta; płatność 90 dni lub 7 dni z 2,5% rabatu</a:t>
-            </a:r>
-            <a:endParaRPr lang="en-US" sz="1250" dirty="0"/>
-          </a:p>
-          <a:p>
-            <a:pPr marL="152400" indent="-152400">
-              <a:spcAft>
-                <a:spcPts val="500"/>
-              </a:spcAft>
-              <a:buSzPct val="100000"/>
-              <a:buChar char="•"/>
-            </a:pPr>
-            <a:r>
-              <a:rPr lang="en-US" sz="1250" dirty="0">
-                <a:solidFill>
-                  <a:srgbClr val="30597A"/>
-                </a:solidFill>
-                <a:latin typeface="Calibri" pitchFamily="34" charset="0"/>
-                <a:ea typeface="Calibri" pitchFamily="34" charset="-122"/>
-                <a:cs typeface="Calibri" pitchFamily="34" charset="-120"/>
-              </a:rPr>
-              <a:t>Od 12.06 klienci przypisani do KAM + cotygodniowy raport KPI</a:t>
-            </a:r>
-            <a:endParaRPr lang="en-US" sz="1250" dirty="0"/>
-          </a:p>
-        </p:txBody>
-      </p:sp>
-      <p:sp>
-        <p:nvSpPr>
-          <p:cNvPr id="13" name="Shape 9"/>
-          <p:cNvSpPr/>
-          <p:nvPr/>
-        </p:nvSpPr>
-        <p:spPr>
-          <a:xfrm>
-            <a:off x="6172200" y="1188720"/>
-            <a:ext cx="2697480" cy="457200"/>
-          </a:xfrm>
-          <a:prstGeom prst="rect">
-            <a:avLst/>
-          </a:prstGeom>
-          <a:solidFill>
-            <a:srgbClr val="174769"/>
-          </a:solidFill>
-          <a:ln w="12700">
-            <a:solidFill>
-              <a:srgbClr val="174769"/>
-            </a:solidFill>
-            <a:prstDash val="solid"/>
-          </a:ln>
-        </p:spPr>
-      </p:sp>
-      <p:pic>
-        <p:nvPicPr>
-          <p:cNvPr id="14" name="Image 2" descr="preencoded.png">    </p:cNvPr>
-          <p:cNvPicPr>
-            <a:picLocks noChangeAspect="1"/>
-          </p:cNvPicPr>
-          <p:nvPr/>
-        </p:nvPicPr>
-        <p:blipFill>
-          <a:blip r:embed="rId3"/>
-          <a:stretch>
-            <a:fillRect/>
-          </a:stretch>
-        </p:blipFill>
-        <p:spPr>
-          <a:xfrm>
-            <a:off x="6336792" y="1307592"/>
-            <a:ext cx="219456" cy="219456"/>
-          </a:xfrm>
-          <a:prstGeom prst="rect">
-            <a:avLst/>
-          </a:prstGeom>
-        </p:spPr>
-      </p:pic>
-      <p:sp>
-        <p:nvSpPr>
-          <p:cNvPr id="15" name="Text 10"/>
-          <p:cNvSpPr txBox="1"/>
-          <p:nvPr/>
-        </p:nvSpPr>
-        <p:spPr>
-          <a:xfrm>
-            <a:off x="6647688" y="1188720"/>
-            <a:ext cx="2148840" cy="457200"/>
-          </a:xfrm>
-          <a:prstGeom prst="rect">
-            <a:avLst/>
-          </a:prstGeom>
-          <a:noFill/>
-          <a:ln/>
-        </p:spPr>
-        <p:txBody>
-          <a:bodyPr wrap="square" lIns="0" tIns="0" rIns="0" bIns="0" rtlCol="0" anchor="ctr"/>
-          <a:lstStyle/>
-          <a:p>
-            <a:pPr indent="0" marL="0">
-              <a:buNone/>
-            </a:pPr>
-            <a:r>
-              <a:rPr lang="en-US" sz="1600" b="1" dirty="0">
-                <a:solidFill>
-                  <a:srgbClr val="FFFFFF"/>
-                </a:solidFill>
-                <a:latin typeface="Calibri" pitchFamily="34" charset="0"/>
-                <a:ea typeface="Calibri" pitchFamily="34" charset="-122"/>
-                <a:cs typeface="Calibri" pitchFamily="34" charset="-120"/>
-              </a:rPr>
-              <a:t>Co zadziałało</a:t>
-            </a:r>
-            <a:endParaRPr lang="en-US" sz="1600" dirty="0"/>
-          </a:p>
-        </p:txBody>
-      </p:sp>
-      <p:sp>
-        <p:nvSpPr>
-          <p:cNvPr id="16" name="Shape 11"/>
-          <p:cNvSpPr/>
-          <p:nvPr/>
-        </p:nvSpPr>
-        <p:spPr>
-          <a:xfrm>
-            <a:off x="6172200" y="1737360"/>
-            <a:ext cx="2697480" cy="2880360"/>
-          </a:xfrm>
-          <a:prstGeom prst="rect">
-            <a:avLst/>
-          </a:prstGeom>
-          <a:solidFill>
-            <a:srgbClr val="FFFFFF"/>
-          </a:solidFill>
-          <a:ln w="15875">
-            <a:solidFill>
-              <a:srgbClr val="174769"/>
-            </a:solidFill>
-            <a:prstDash val="solid"/>
-          </a:ln>
-        </p:spPr>
-      </p:sp>
-      <p:sp>
-        <p:nvSpPr>
-          <p:cNvPr id="17" name="Text 12"/>
-          <p:cNvSpPr txBox="1"/>
-          <p:nvPr/>
-        </p:nvSpPr>
-        <p:spPr>
-          <a:xfrm>
-            <a:off x="6309360" y="1874520"/>
-            <a:ext cx="2441448" cy="2651760"/>
-          </a:xfrm>
-          <a:prstGeom prst="rect">
-            <a:avLst/>
-          </a:prstGeom>
-          <a:noFill/>
-          <a:ln/>
-        </p:spPr>
-        <p:txBody>
-          <a:bodyPr wrap="square" lIns="0" tIns="0" rIns="0" bIns="0" rtlCol="0" anchor="t"/>
-          <a:lstStyle/>
-          <a:p>
-            <a:pPr marL="152400" indent="-152400">
-              <a:spcAft>
-                <a:spcPts val="500"/>
-              </a:spcAft>
-              <a:buSzPct val="100000"/>
-              <a:buChar char="•"/>
-            </a:pPr>
-            <a:r>
-              <a:rPr lang="en-US" sz="1250" dirty="0">
-                <a:solidFill>
-                  <a:srgbClr val="30597A"/>
-                </a:solidFill>
-                <a:latin typeface="Calibri" pitchFamily="34" charset="0"/>
-                <a:ea typeface="Calibri" pitchFamily="34" charset="-122"/>
-                <a:cs typeface="Calibri" pitchFamily="34" charset="-120"/>
-              </a:rPr>
-              <a:t>174 kont (105% bazy), 127 z zamówieniem</a:t>
-            </a:r>
-            <a:endParaRPr lang="en-US" sz="1250" dirty="0"/>
-          </a:p>
-          <a:p>
-            <a:pPr marL="152400" indent="-152400">
-              <a:spcAft>
-                <a:spcPts val="500"/>
-              </a:spcAft>
-              <a:buSzPct val="100000"/>
-              <a:buChar char="•"/>
-            </a:pPr>
-            <a:r>
-              <a:rPr lang="en-US" sz="1250" dirty="0">
-                <a:solidFill>
-                  <a:srgbClr val="30597A"/>
-                </a:solidFill>
-                <a:latin typeface="Calibri" pitchFamily="34" charset="0"/>
-                <a:ea typeface="Calibri" pitchFamily="34" charset="-122"/>
-                <a:cs typeface="Calibri" pitchFamily="34" charset="-120"/>
-              </a:rPr>
-              <a:t>422,4 tys. € = 91% budżetu, 94% planu do dziś</a:t>
-            </a:r>
-            <a:endParaRPr lang="en-US" sz="1250" dirty="0"/>
-          </a:p>
-          <a:p>
-            <a:pPr marL="152400" indent="-152400">
-              <a:spcAft>
-                <a:spcPts val="500"/>
-              </a:spcAft>
-              <a:buSzPct val="100000"/>
-              <a:buChar char="•"/>
-            </a:pPr>
-            <a:r>
-              <a:rPr lang="en-US" sz="1250" dirty="0">
-                <a:solidFill>
-                  <a:srgbClr val="30597A"/>
-                </a:solidFill>
-                <a:latin typeface="Calibri" pitchFamily="34" charset="0"/>
-                <a:ea typeface="Calibri" pitchFamily="34" charset="-122"/>
-                <a:cs typeface="Calibri" pitchFamily="34" charset="-120"/>
-              </a:rPr>
-              <a:t>59% klientów wraca z 2. zamówieniem w ciągu 60 dni</a:t>
-            </a:r>
-            <a:endParaRPr lang="en-US" sz="1250" dirty="0"/>
-          </a:p>
-          <a:p>
-            <a:pPr marL="152400" indent="-152400">
-              <a:spcAft>
-                <a:spcPts val="500"/>
-              </a:spcAft>
-              <a:buSzPct val="100000"/>
-              <a:buChar char="•"/>
-            </a:pPr>
-            <a:r>
-              <a:rPr lang="en-US" sz="1250" dirty="0">
-                <a:solidFill>
-                  <a:srgbClr val="30597A"/>
-                </a:solidFill>
-                <a:latin typeface="Calibri" pitchFamily="34" charset="0"/>
-                <a:ea typeface="Calibri" pitchFamily="34" charset="-122"/>
-                <a:cs typeface="Calibri" pitchFamily="34" charset="-120"/>
-              </a:rPr>
-              <a:t>Część klientów zamawia sama, bez telefonu do PH</a:t>
-            </a:r>
-            <a:endParaRPr lang="en-US" sz="1250" dirty="0"/>
-          </a:p>
-        </p:txBody>
-      </p:sp>
-      <p:sp>
-        <p:nvSpPr>
-          <p:cNvPr id="18" name="Shape 13"/>
-          <p:cNvSpPr/>
-          <p:nvPr/>
-        </p:nvSpPr>
-        <p:spPr>
-          <a:xfrm>
-            <a:off x="9052560" y="1188720"/>
-            <a:ext cx="2697480" cy="457200"/>
-          </a:xfrm>
-          <a:prstGeom prst="rect">
-            <a:avLst/>
-          </a:prstGeom>
-          <a:solidFill>
-            <a:srgbClr val="174769"/>
-          </a:solidFill>
-          <a:ln w="12700">
-            <a:solidFill>
-              <a:srgbClr val="174769"/>
-            </a:solidFill>
-            <a:prstDash val="solid"/>
-          </a:ln>
-        </p:spPr>
-      </p:sp>
-      <p:pic>
-        <p:nvPicPr>
-          <p:cNvPr id="19" name="Image 3" descr="preencoded.png">    </p:cNvPr>
-          <p:cNvPicPr>
-            <a:picLocks noChangeAspect="1"/>
-          </p:cNvPicPr>
-          <p:nvPr/>
-        </p:nvPicPr>
-        <p:blipFill>
-          <a:blip r:embed="rId4"/>
-          <a:stretch>
-            <a:fillRect/>
-          </a:stretch>
-        </p:blipFill>
-        <p:spPr>
-          <a:xfrm>
-            <a:off x="9217152" y="1307592"/>
-            <a:ext cx="219456" cy="219456"/>
-          </a:xfrm>
-          <a:prstGeom prst="rect">
-            <a:avLst/>
-          </a:prstGeom>
-        </p:spPr>
-      </p:pic>
-      <p:sp>
-        <p:nvSpPr>
-          <p:cNvPr id="20" name="Text 14"/>
-          <p:cNvSpPr txBox="1"/>
-          <p:nvPr/>
-        </p:nvSpPr>
-        <p:spPr>
-          <a:xfrm>
-            <a:off x="9528048" y="1188720"/>
-            <a:ext cx="2148840" cy="457200"/>
-          </a:xfrm>
-          <a:prstGeom prst="rect">
-            <a:avLst/>
-          </a:prstGeom>
-          <a:noFill/>
-          <a:ln/>
-        </p:spPr>
-        <p:txBody>
-          <a:bodyPr wrap="square" lIns="0" tIns="0" rIns="0" bIns="0" rtlCol="0" anchor="ctr"/>
-          <a:lstStyle/>
-          <a:p>
-            <a:pPr indent="0" marL="0">
-              <a:buNone/>
-            </a:pPr>
-            <a:r>
-              <a:rPr lang="en-US" sz="1600" b="1" dirty="0">
-                <a:solidFill>
-                  <a:srgbClr val="FFFFFF"/>
-                </a:solidFill>
-                <a:latin typeface="Calibri" pitchFamily="34" charset="0"/>
-                <a:ea typeface="Calibri" pitchFamily="34" charset="-122"/>
-                <a:cs typeface="Calibri" pitchFamily="34" charset="-120"/>
-              </a:rPr>
-              <a:t>Co nie zadziałało</a:t>
-            </a:r>
-            <a:endParaRPr lang="en-US" sz="1600" dirty="0"/>
-          </a:p>
-        </p:txBody>
-      </p:sp>
-      <p:sp>
-        <p:nvSpPr>
-          <p:cNvPr id="21" name="Shape 15"/>
-          <p:cNvSpPr/>
-          <p:nvPr/>
-        </p:nvSpPr>
-        <p:spPr>
-          <a:xfrm>
-            <a:off x="9052560" y="1737360"/>
-            <a:ext cx="2697480" cy="2880360"/>
-          </a:xfrm>
-          <a:prstGeom prst="rect">
-            <a:avLst/>
-          </a:prstGeom>
-          <a:solidFill>
-            <a:srgbClr val="FFFFFF"/>
-          </a:solidFill>
-          <a:ln w="15875">
-            <a:solidFill>
-              <a:srgbClr val="174769"/>
-            </a:solidFill>
-            <a:prstDash val="solid"/>
-          </a:ln>
-        </p:spPr>
-      </p:sp>
-      <p:sp>
-        <p:nvSpPr>
-          <p:cNvPr id="22" name="Text 16"/>
-          <p:cNvSpPr txBox="1"/>
-          <p:nvPr/>
-        </p:nvSpPr>
-        <p:spPr>
-          <a:xfrm>
-            <a:off x="9189720" y="1874520"/>
-            <a:ext cx="2441448" cy="2651760"/>
-          </a:xfrm>
-          <a:prstGeom prst="rect">
-            <a:avLst/>
-          </a:prstGeom>
-          <a:noFill/>
-          <a:ln/>
-        </p:spPr>
-        <p:txBody>
-          <a:bodyPr wrap="square" lIns="0" tIns="0" rIns="0" bIns="0" rtlCol="0" anchor="t"/>
-          <a:lstStyle/>
-          <a:p>
-            <a:pPr marL="152400" indent="-152400">
-              <a:spcAft>
-                <a:spcPts val="500"/>
-              </a:spcAft>
-              <a:buSzPct val="100000"/>
-              <a:buChar char="•"/>
-            </a:pPr>
-            <a:r>
-              <a:rPr lang="en-US" sz="1250" dirty="0">
-                <a:solidFill>
-                  <a:srgbClr val="30597A"/>
-                </a:solidFill>
-                <a:latin typeface="Calibri" pitchFamily="34" charset="0"/>
-                <a:ea typeface="Calibri" pitchFamily="34" charset="-122"/>
-                <a:cs typeface="Calibri" pitchFamily="34" charset="-120"/>
-              </a:rPr>
-              <a:t>317 zamówień = 34% celu: rzadkie, duże zamówienia „na stock”</a:t>
-            </a:r>
-            <a:endParaRPr lang="en-US" sz="1250" dirty="0"/>
-          </a:p>
-          <a:p>
-            <a:pPr marL="152400" indent="-152400">
-              <a:spcAft>
-                <a:spcPts val="500"/>
-              </a:spcAft>
-              <a:buSzPct val="100000"/>
-              <a:buChar char="•"/>
-            </a:pPr>
-            <a:r>
-              <a:rPr lang="en-US" sz="1250" dirty="0">
-                <a:solidFill>
-                  <a:srgbClr val="30597A"/>
-                </a:solidFill>
-                <a:latin typeface="Calibri" pitchFamily="34" charset="0"/>
-                <a:ea typeface="Calibri" pitchFamily="34" charset="-122"/>
-                <a:cs typeface="Calibri" pitchFamily="34" charset="-120"/>
-              </a:rPr>
-              <a:t>Brak kampanii B2B i kontaktu w sezonie (newsletter, SMS)</a:t>
-            </a:r>
-            <a:endParaRPr lang="en-US" sz="1250" dirty="0"/>
-          </a:p>
-          <a:p>
-            <a:pPr marL="152400" indent="-152400">
-              <a:spcAft>
-                <a:spcPts val="500"/>
-              </a:spcAft>
-              <a:buSzPct val="100000"/>
-              <a:buChar char="•"/>
-            </a:pPr>
-            <a:r>
-              <a:rPr lang="en-US" sz="1250" dirty="0">
-                <a:solidFill>
-                  <a:srgbClr val="30597A"/>
-                </a:solidFill>
-                <a:latin typeface="Calibri" pitchFamily="34" charset="0"/>
-                <a:ea typeface="Calibri" pitchFamily="34" charset="-122"/>
-                <a:cs typeface="Calibri" pitchFamily="34" charset="-120"/>
-              </a:rPr>
-              <a:t>Korekty cen ręcznie w Sage: klient widzi inne kwoty niż na fakturze, brak śledzenia przesyłek</a:t>
-            </a:r>
-            <a:endParaRPr lang="en-US" sz="1250" dirty="0"/>
-          </a:p>
-          <a:p>
-            <a:pPr marL="152400" indent="-152400">
-              <a:spcAft>
-                <a:spcPts val="500"/>
-              </a:spcAft>
-              <a:buSzPct val="100000"/>
-              <a:buChar char="•"/>
-            </a:pPr>
-            <a:r>
-              <a:rPr lang="en-US" sz="1250" dirty="0">
-                <a:solidFill>
-                  <a:srgbClr val="30597A"/>
-                </a:solidFill>
-                <a:latin typeface="Calibri" pitchFamily="34" charset="0"/>
-                <a:ea typeface="Calibri" pitchFamily="34" charset="-122"/>
-                <a:cs typeface="Calibri" pitchFamily="34" charset="-120"/>
-              </a:rPr>
-              <a:t>Brak programu lojalnościowego, niewygodny panel</a:t>
-            </a:r>
-            <a:endParaRPr lang="en-US" sz="1250" dirty="0"/>
-          </a:p>
-        </p:txBody>
-      </p:sp>
-      <p:sp>
-        <p:nvSpPr>
-          <p:cNvPr id="23" name="Shape 17"/>
-          <p:cNvSpPr/>
-          <p:nvPr/>
-        </p:nvSpPr>
-        <p:spPr>
-          <a:xfrm>
-            <a:off x="411480" y="4800600"/>
-            <a:ext cx="11338560" cy="1691640"/>
-          </a:xfrm>
-          <a:prstGeom prst="rect">
-            <a:avLst/>
-          </a:prstGeom>
-          <a:solidFill>
-            <a:srgbClr val="174769"/>
-          </a:solidFill>
-          <a:ln w="12700">
-            <a:solidFill>
-              <a:srgbClr val="174769"/>
-            </a:solidFill>
-            <a:prstDash val="solid"/>
-          </a:ln>
-        </p:spPr>
-      </p:sp>
-      <p:sp>
-        <p:nvSpPr>
-          <p:cNvPr id="24" name="Text 18"/>
-          <p:cNvSpPr txBox="1"/>
-          <p:nvPr/>
-        </p:nvSpPr>
-        <p:spPr>
-          <a:xfrm>
-            <a:off x="685800" y="4937760"/>
-            <a:ext cx="5486400" cy="320040"/>
-          </a:xfrm>
-          <a:prstGeom prst="rect">
-            <a:avLst/>
-          </a:prstGeom>
-          <a:noFill/>
-          <a:ln/>
-        </p:spPr>
-        <p:txBody>
-          <a:bodyPr wrap="square" lIns="0" tIns="0" rIns="0" bIns="0" rtlCol="0" anchor="ctr"/>
-          <a:lstStyle/>
-          <a:p>
-            <a:pPr indent="0" marL="0">
-              <a:buNone/>
-            </a:pPr>
-            <a:r>
-              <a:rPr lang="en-US" sz="1600" b="1" dirty="0">
-                <a:solidFill>
-                  <a:srgbClr val="F8AF2D"/>
-                </a:solidFill>
-                <a:latin typeface="Calibri" pitchFamily="34" charset="0"/>
-                <a:ea typeface="Calibri" pitchFamily="34" charset="-122"/>
-                <a:cs typeface="Calibri" pitchFamily="34" charset="-120"/>
-              </a:rPr>
-              <a:t>LEARNINGI NA FY27</a:t>
-            </a:r>
-            <a:endParaRPr lang="en-US" sz="1600" dirty="0"/>
-          </a:p>
-        </p:txBody>
-      </p:sp>
-      <p:sp>
-        <p:nvSpPr>
-          <p:cNvPr id="25" name="Shape 19"/>
-          <p:cNvSpPr/>
-          <p:nvPr/>
-        </p:nvSpPr>
-        <p:spPr>
-          <a:xfrm>
-            <a:off x="685800" y="5422392"/>
-            <a:ext cx="384048" cy="384048"/>
-          </a:xfrm>
-          <a:prstGeom prst="ellipse">
-            <a:avLst/>
-          </a:prstGeom>
-          <a:solidFill>
-            <a:srgbClr val="F8AF2D"/>
-          </a:solidFill>
-          <a:ln w="12700">
-            <a:solidFill>
-              <a:srgbClr val="F8AF2D"/>
-            </a:solidFill>
-            <a:prstDash val="solid"/>
-          </a:ln>
-        </p:spPr>
-      </p:sp>
-      <p:sp>
-        <p:nvSpPr>
-          <p:cNvPr id="26" name="Text 20"/>
-          <p:cNvSpPr txBox="1"/>
-          <p:nvPr/>
-        </p:nvSpPr>
-        <p:spPr>
-          <a:xfrm>
-            <a:off x="685800" y="5422392"/>
-            <a:ext cx="384048" cy="384048"/>
-          </a:xfrm>
-          <a:prstGeom prst="rect">
-            <a:avLst/>
-          </a:prstGeom>
-          <a:noFill/>
-          <a:ln/>
-        </p:spPr>
-        <p:txBody>
-          <a:bodyPr wrap="square" lIns="0" tIns="0" rIns="0" bIns="0" rtlCol="0" anchor="ctr"/>
-          <a:lstStyle/>
-          <a:p>
-            <a:pPr algn="ctr" indent="0" marL="0">
-              <a:buNone/>
-            </a:pPr>
-            <a:r>
-              <a:rPr lang="en-US" sz="1500" b="1" dirty="0">
-                <a:solidFill>
-                  <a:srgbClr val="174769"/>
-                </a:solidFill>
-                <a:latin typeface="Calibri" pitchFamily="34" charset="0"/>
-                <a:ea typeface="Calibri" pitchFamily="34" charset="-122"/>
-                <a:cs typeface="Calibri" pitchFamily="34" charset="-120"/>
-              </a:rPr>
-              <a:t>1</a:t>
-            </a:r>
-            <a:endParaRPr lang="en-US" sz="1500" dirty="0"/>
-          </a:p>
-        </p:txBody>
-      </p:sp>
-      <p:sp>
-        <p:nvSpPr>
-          <p:cNvPr id="27" name="Text 21"/>
-          <p:cNvSpPr txBox="1"/>
-          <p:nvPr/>
-        </p:nvSpPr>
-        <p:spPr>
-          <a:xfrm>
-            <a:off x="1161288" y="5330952"/>
-            <a:ext cx="2121408" cy="1051560"/>
-          </a:xfrm>
-          <a:prstGeom prst="rect">
-            <a:avLst/>
-          </a:prstGeom>
-          <a:noFill/>
-          <a:ln/>
-        </p:spPr>
-        <p:txBody>
-          <a:bodyPr wrap="square" lIns="0" tIns="0" rIns="0" bIns="0" rtlCol="0" anchor="t"/>
-          <a:lstStyle/>
-          <a:p>
-            <a:pPr indent="0" marL="0">
-              <a:buNone/>
-            </a:pPr>
-            <a:r>
-              <a:rPr lang="en-US" sz="1250" dirty="0">
-                <a:solidFill>
-                  <a:srgbClr val="FFFFFF"/>
-                </a:solidFill>
-                <a:latin typeface="Calibri" pitchFamily="34" charset="0"/>
-                <a:ea typeface="Calibri" pitchFamily="34" charset="-122"/>
-                <a:cs typeface="Calibri" pitchFamily="34" charset="-120"/>
-              </a:rPr>
-              <a:t>Kampania B2B i budżet mediowy, nie tylko pozyskanie przez PH</a:t>
-            </a:r>
-            <a:endParaRPr lang="en-US" sz="1250" dirty="0"/>
-          </a:p>
-        </p:txBody>
-      </p:sp>
-      <p:sp>
-        <p:nvSpPr>
-          <p:cNvPr id="28" name="Shape 22"/>
-          <p:cNvSpPr/>
-          <p:nvPr/>
-        </p:nvSpPr>
-        <p:spPr>
-          <a:xfrm>
-            <a:off x="3447288" y="5422392"/>
-            <a:ext cx="384048" cy="384048"/>
-          </a:xfrm>
-          <a:prstGeom prst="ellipse">
-            <a:avLst/>
-          </a:prstGeom>
-          <a:solidFill>
-            <a:srgbClr val="F8AF2D"/>
-          </a:solidFill>
-          <a:ln w="12700">
-            <a:solidFill>
-              <a:srgbClr val="F8AF2D"/>
-            </a:solidFill>
-            <a:prstDash val="solid"/>
-          </a:ln>
-        </p:spPr>
-      </p:sp>
-      <p:sp>
-        <p:nvSpPr>
-          <p:cNvPr id="29" name="Text 23"/>
-          <p:cNvSpPr txBox="1"/>
-          <p:nvPr/>
-        </p:nvSpPr>
-        <p:spPr>
-          <a:xfrm>
-            <a:off x="3447288" y="5422392"/>
-            <a:ext cx="384048" cy="384048"/>
-          </a:xfrm>
-          <a:prstGeom prst="rect">
-            <a:avLst/>
-          </a:prstGeom>
-          <a:noFill/>
-          <a:ln/>
-        </p:spPr>
-        <p:txBody>
-          <a:bodyPr wrap="square" lIns="0" tIns="0" rIns="0" bIns="0" rtlCol="0" anchor="ctr"/>
-          <a:lstStyle/>
-          <a:p>
-            <a:pPr algn="ctr" indent="0" marL="0">
-              <a:buNone/>
-            </a:pPr>
-            <a:r>
-              <a:rPr lang="en-US" sz="1500" b="1" dirty="0">
-                <a:solidFill>
-                  <a:srgbClr val="174769"/>
-                </a:solidFill>
-                <a:latin typeface="Calibri" pitchFamily="34" charset="0"/>
-                <a:ea typeface="Calibri" pitchFamily="34" charset="-122"/>
-                <a:cs typeface="Calibri" pitchFamily="34" charset="-120"/>
-              </a:rPr>
-              <a:t>2</a:t>
-            </a:r>
-            <a:endParaRPr lang="en-US" sz="1500" dirty="0"/>
-          </a:p>
-        </p:txBody>
-      </p:sp>
-      <p:sp>
-        <p:nvSpPr>
-          <p:cNvPr id="30" name="Text 24"/>
-          <p:cNvSpPr txBox="1"/>
-          <p:nvPr/>
-        </p:nvSpPr>
-        <p:spPr>
-          <a:xfrm>
-            <a:off x="3922776" y="5330952"/>
-            <a:ext cx="2121408" cy="1051560"/>
-          </a:xfrm>
-          <a:prstGeom prst="rect">
-            <a:avLst/>
-          </a:prstGeom>
-          <a:noFill/>
-          <a:ln/>
-        </p:spPr>
-        <p:txBody>
-          <a:bodyPr wrap="square" lIns="0" tIns="0" rIns="0" bIns="0" rtlCol="0" anchor="t"/>
-          <a:lstStyle/>
-          <a:p>
-            <a:pPr indent="0" marL="0">
-              <a:buNone/>
-            </a:pPr>
-            <a:r>
-              <a:rPr lang="en-US" sz="1250" dirty="0">
-                <a:solidFill>
-                  <a:srgbClr val="FFFFFF"/>
-                </a:solidFill>
-                <a:latin typeface="Calibri" pitchFamily="34" charset="0"/>
-                <a:ea typeface="Calibri" pitchFamily="34" charset="-122"/>
-                <a:cs typeface="Calibri" pitchFamily="34" charset="-120"/>
-              </a:rPr>
-              <a:t>Program partnerski: punkty za zgody marketingowe i częstsze zamówienia</a:t>
-            </a:r>
-            <a:endParaRPr lang="en-US" sz="1250" dirty="0"/>
-          </a:p>
-        </p:txBody>
-      </p:sp>
-      <p:sp>
-        <p:nvSpPr>
-          <p:cNvPr id="31" name="Shape 25"/>
-          <p:cNvSpPr/>
-          <p:nvPr/>
-        </p:nvSpPr>
-        <p:spPr>
-          <a:xfrm>
-            <a:off x="6208776" y="5422392"/>
-            <a:ext cx="384048" cy="384048"/>
-          </a:xfrm>
-          <a:prstGeom prst="ellipse">
-            <a:avLst/>
-          </a:prstGeom>
-          <a:solidFill>
-            <a:srgbClr val="F8AF2D"/>
-          </a:solidFill>
-          <a:ln w="12700">
-            <a:solidFill>
-              <a:srgbClr val="F8AF2D"/>
-            </a:solidFill>
-            <a:prstDash val="solid"/>
-          </a:ln>
-        </p:spPr>
-      </p:sp>
-      <p:sp>
-        <p:nvSpPr>
-          <p:cNvPr id="32" name="Text 26"/>
-          <p:cNvSpPr txBox="1"/>
-          <p:nvPr/>
-        </p:nvSpPr>
-        <p:spPr>
-          <a:xfrm>
-            <a:off x="6208776" y="5422392"/>
-            <a:ext cx="384048" cy="384048"/>
-          </a:xfrm>
-          <a:prstGeom prst="rect">
-            <a:avLst/>
-          </a:prstGeom>
-          <a:noFill/>
-          <a:ln/>
-        </p:spPr>
-        <p:txBody>
-          <a:bodyPr wrap="square" lIns="0" tIns="0" rIns="0" bIns="0" rtlCol="0" anchor="ctr"/>
-          <a:lstStyle/>
-          <a:p>
-            <a:pPr algn="ctr" indent="0" marL="0">
-              <a:buNone/>
-            </a:pPr>
-            <a:r>
-              <a:rPr lang="en-US" sz="1500" b="1" dirty="0">
-                <a:solidFill>
-                  <a:srgbClr val="174769"/>
-                </a:solidFill>
-                <a:latin typeface="Calibri" pitchFamily="34" charset="0"/>
-                <a:ea typeface="Calibri" pitchFamily="34" charset="-122"/>
-                <a:cs typeface="Calibri" pitchFamily="34" charset="-120"/>
-              </a:rPr>
-              <a:t>3</a:t>
-            </a:r>
-            <a:endParaRPr lang="en-US" sz="1500" dirty="0"/>
-          </a:p>
-        </p:txBody>
-      </p:sp>
-      <p:sp>
-        <p:nvSpPr>
-          <p:cNvPr id="33" name="Text 27"/>
-          <p:cNvSpPr txBox="1"/>
-          <p:nvPr/>
-        </p:nvSpPr>
-        <p:spPr>
-          <a:xfrm>
-            <a:off x="6684264" y="5330952"/>
-            <a:ext cx="2121408" cy="1051560"/>
-          </a:xfrm>
-          <a:prstGeom prst="rect">
-            <a:avLst/>
-          </a:prstGeom>
-          <a:noFill/>
-          <a:ln/>
-        </p:spPr>
-        <p:txBody>
-          <a:bodyPr wrap="square" lIns="0" tIns="0" rIns="0" bIns="0" rtlCol="0" anchor="t"/>
-          <a:lstStyle/>
-          <a:p>
-            <a:pPr indent="0" marL="0">
-              <a:buNone/>
-            </a:pPr>
-            <a:r>
-              <a:rPr lang="en-US" sz="1250" dirty="0">
-                <a:solidFill>
-                  <a:srgbClr val="FFFFFF"/>
-                </a:solidFill>
-                <a:latin typeface="Calibri" pitchFamily="34" charset="0"/>
-                <a:ea typeface="Calibri" pitchFamily="34" charset="-122"/>
-                <a:cs typeface="Calibri" pitchFamily="34" charset="-120"/>
-              </a:rPr>
-              <a:t>Prostszy panel + codzienny import z Sage: kwoty jak na fakturze, nr listu przewozowego</a:t>
-            </a:r>
-            <a:endParaRPr lang="en-US" sz="1250" dirty="0"/>
-          </a:p>
-        </p:txBody>
-      </p:sp>
-      <p:sp>
-        <p:nvSpPr>
-          <p:cNvPr id="34" name="Shape 28"/>
-          <p:cNvSpPr/>
-          <p:nvPr/>
-        </p:nvSpPr>
-        <p:spPr>
-          <a:xfrm>
-            <a:off x="8970264" y="5422392"/>
-            <a:ext cx="384048" cy="384048"/>
-          </a:xfrm>
-          <a:prstGeom prst="ellipse">
-            <a:avLst/>
-          </a:prstGeom>
-          <a:solidFill>
-            <a:srgbClr val="F8AF2D"/>
-          </a:solidFill>
-          <a:ln w="12700">
-            <a:solidFill>
-              <a:srgbClr val="F8AF2D"/>
-            </a:solidFill>
-            <a:prstDash val="solid"/>
-          </a:ln>
-        </p:spPr>
-      </p:sp>
-      <p:sp>
-        <p:nvSpPr>
-          <p:cNvPr id="35" name="Text 29"/>
-          <p:cNvSpPr txBox="1"/>
-          <p:nvPr/>
-        </p:nvSpPr>
-        <p:spPr>
-          <a:xfrm>
-            <a:off x="8970264" y="5422392"/>
-            <a:ext cx="384048" cy="384048"/>
-          </a:xfrm>
-          <a:prstGeom prst="rect">
-            <a:avLst/>
-          </a:prstGeom>
-          <a:noFill/>
-          <a:ln/>
-        </p:spPr>
-        <p:txBody>
-          <a:bodyPr wrap="square" lIns="0" tIns="0" rIns="0" bIns="0" rtlCol="0" anchor="ctr"/>
-          <a:lstStyle/>
-          <a:p>
-            <a:pPr algn="ctr" indent="0" marL="0">
-              <a:buNone/>
-            </a:pPr>
-            <a:r>
-              <a:rPr lang="en-US" sz="1500" b="1" dirty="0">
-                <a:solidFill>
-                  <a:srgbClr val="174769"/>
-                </a:solidFill>
-                <a:latin typeface="Calibri" pitchFamily="34" charset="0"/>
-                <a:ea typeface="Calibri" pitchFamily="34" charset="-122"/>
-                <a:cs typeface="Calibri" pitchFamily="34" charset="-120"/>
-              </a:rPr>
-              <a:t>4</a:t>
-            </a:r>
-            <a:endParaRPr lang="en-US" sz="1500" dirty="0"/>
-          </a:p>
-        </p:txBody>
-      </p:sp>
-      <p:sp>
-        <p:nvSpPr>
-          <p:cNvPr id="36" name="Text 30"/>
-          <p:cNvSpPr txBox="1"/>
-          <p:nvPr/>
-        </p:nvSpPr>
-        <p:spPr>
-          <a:xfrm>
-            <a:off x="9445752" y="5330952"/>
-            <a:ext cx="2121408" cy="1051560"/>
-          </a:xfrm>
-          <a:prstGeom prst="rect">
-            <a:avLst/>
-          </a:prstGeom>
-          <a:noFill/>
-          <a:ln/>
-        </p:spPr>
-        <p:txBody>
-          <a:bodyPr wrap="square" lIns="0" tIns="0" rIns="0" bIns="0" rtlCol="0" anchor="t"/>
-          <a:lstStyle/>
-          <a:p>
-            <a:pPr indent="0" marL="0">
-              <a:buNone/>
-            </a:pPr>
-            <a:r>
-              <a:rPr lang="en-US" sz="1250" dirty="0">
-                <a:solidFill>
-                  <a:srgbClr val="FFFFFF"/>
-                </a:solidFill>
-                <a:latin typeface="Calibri" pitchFamily="34" charset="0"/>
-                <a:ea typeface="Calibri" pitchFamily="34" charset="-122"/>
-                <a:cs typeface="Calibri" pitchFamily="34" charset="-120"/>
-              </a:rPr>
-              <a:t>Liczymy konta, które zamawiają, i częstotliwość, nie rejestracje</a:t>
-            </a:r>
-            <a:endParaRPr lang="en-US" sz="1250" dirty="0"/>
-          </a:p>
-        </p:txBody>
-      </p:sp>
-    </p:spTree>
-  </p:cSld>
-  <p:clrMapOvr>
-    <a:masterClrMapping/>
-  </p:clrMapOvr>
-</p:sld>
-</file>
-
-<file path=ppt/slides/slide4.xml><?xml version="1.0" encoding="utf-8"?>
-<p:sld xmlns:a="http://schemas.openxmlformats.org/drawingml/2006/main" xmlns:r="http://schemas.openxmlformats.org/officeDocument/2006/relationships" xmlns:p="http://schemas.openxmlformats.org/presentationml/2006/main">
-  <p:cSld name="Slide 4">
-    <p:bg>
-      <p:bgPr>
-        <a:solidFill>
-          <a:srgbClr val="FFFFFF"/>
-        </a:solidFill>
-      </p:bgPr>
-    </p:bg>
-    <p:spTree>
-      <p:nvGrpSpPr>
-        <p:cNvPr id="1" name=""/>
-        <p:cNvGrpSpPr/>
-        <p:nvPr/>
-      </p:nvGrpSpPr>
-      <p:grpSpPr>
-        <a:xfrm>
-          <a:off x="0" y="0"/>
-          <a:ext cx="0" cy="0"/>
-          <a:chOff x="0" y="0"/>
-          <a:chExt cx="0" cy="0"/>
-        </a:xfrm>
-      </p:grpSpPr>
-      <p:sp>
-        <p:nvSpPr>
-          <p:cNvPr id="2" name="Text 0"/>
-          <p:cNvSpPr txBox="1"/>
-          <p:nvPr/>
-        </p:nvSpPr>
-        <p:spPr>
-          <a:xfrm>
-            <a:off x="411480" y="274320"/>
-            <a:ext cx="11338560" cy="731520"/>
-          </a:xfrm>
-          <a:prstGeom prst="rect">
-            <a:avLst/>
-          </a:prstGeom>
-          <a:noFill/>
-          <a:ln/>
-        </p:spPr>
-        <p:txBody>
-          <a:bodyPr wrap="square" lIns="0" tIns="0" rIns="0" bIns="0" rtlCol="0" anchor="ctr"/>
-          <a:lstStyle/>
-          <a:p>
-            <a:pPr indent="0" marL="0">
-              <a:buNone/>
-            </a:pPr>
-            <a:r>
-              <a:rPr lang="en-US" sz="4000" b="1" dirty="0">
-                <a:solidFill>
-                  <a:srgbClr val="108C96"/>
-                </a:solidFill>
-                <a:latin typeface="Calibri" pitchFamily="34" charset="0"/>
-                <a:ea typeface="Calibri" pitchFamily="34" charset="-122"/>
-                <a:cs typeface="Calibri" pitchFamily="34" charset="-120"/>
-              </a:rPr>
               <a:t>B2B PL – WYNIK I START FY27</a:t>
             </a:r>
             <a:endParaRPr lang="en-US" sz="4000" dirty="0"/>

</xml_diff>